<commit_message>
feat: update mentor deck and validation reports after role-answer re-run and commit count adjustments
</commit_message>
<xml_diff>
--- a/.copilot-tracking/ppt/2026-09-26/ama-mentor-progress-review/slide-deck/ama-mentor-progress-review.pptx
+++ b/.copilot-tracking/ppt/2026-09-26/ama-mentor-progress-review/slide-deck/ama-mentor-progress-review.pptx
@@ -598,7 +598,7 @@
           <a:p/>
           <a:p>
             <a:r>
-              <a:t>None moved a request to an end-to-end agent. Richer inputs enrich the digital foundation and widen what bounded agents can check, but they add duties before autonomy: special category data, Awaab's Law awareness from the moment a photo arrives, and payment and procurement rules.</a:t>
+              <a:t>None moved a request to an end-to-end agent. Richer inputs enrich the digital foundation and widen what bounded agents can check, but they add duties before autonomy: special category data, Awaab's Law awareness, which a hazard photo can establish no later than its arrival, and payment and procurement rules.</a:t>
             </a:r>
           </a:p>
           <a:p/>
@@ -610,7 +610,7 @@
           <a:p/>
           <a:p>
             <a:r>
-              <a:t>A post-merge review caught two errors: the same Article 22 citation I had fixed in CON-003, and eleven answers from roles that have no agent. I re-ran nine with the nearest roles and labelled two as my own hypotheses.</a:t>
+              <a:t>A post-merge review caught two errors: the same Article 22 citation I had fixed in CON-003, and eleven answers from roles that have no agent. I re-ran nine with the nearest roles and labelled two as my own hypotheses. Then I re-ran every other role answer against the reframed proposal. Every verdict held; six answers tightened controls to match the BRD. For example, AI risk paths stay in shadow mode, and a person approves every AI-drafted message to a resident.</a:t>
             </a:r>
           </a:p>
         </p:txBody>
@@ -5498,7 +5498,7 @@
         <p:spPr>
           <a:xfrm>
             <a:off x="7406640" y="1508760"/>
-            <a:ext cx="4236415" cy="3383280"/>
+            <a:ext cx="4236415" cy="3611880"/>
           </a:xfrm>
           <a:prstGeom prst="roundRect">
             <a:avLst>
@@ -5534,7 +5534,7 @@
           <a:p>
             <a:pPr algn="l">
               <a:spcAft>
-                <a:spcPts val="1200"/>
+                <a:spcPts val="800"/>
               </a:spcAft>
             </a:pPr>
             <a:r>
@@ -5550,7 +5550,7 @@
           <a:p>
             <a:pPr algn="l" marL="228600" indent="-228600">
               <a:spcAft>
-                <a:spcPts val="1200"/>
+                <a:spcPts val="800"/>
               </a:spcAft>
               <a:buChar char="•"/>
             </a:pPr>
@@ -5567,7 +5567,7 @@
           <a:p>
             <a:pPr algn="l" marL="228600" indent="-228600">
               <a:spcAft>
-                <a:spcPts val="1200"/>
+                <a:spcPts val="800"/>
               </a:spcAft>
               <a:buChar char="•"/>
             </a:pPr>
@@ -5584,7 +5584,7 @@
           <a:p>
             <a:pPr algn="l" marL="228600" indent="-228600">
               <a:spcAft>
-                <a:spcPts val="1200"/>
+                <a:spcPts val="800"/>
               </a:spcAft>
               <a:buChar char="•"/>
             </a:pPr>
@@ -5595,13 +5595,13 @@
                 </a:solidFill>
                 <a:latin typeface="Segoe UI"/>
               </a:rPr>
-              <a:t>Duties grow before autonomy: special category data, Awaab's Law awareness, payment and procurement rules</a:t>
+              <a:t>Duties grow before autonomy: special category data, Awaab's Law, payment and procurement rules</a:t>
             </a:r>
           </a:p>
           <a:p>
             <a:pPr algn="l" marL="228600" indent="-228600">
               <a:spcAft>
-                <a:spcPts val="1200"/>
+                <a:spcPts val="800"/>
               </a:spcAft>
               <a:buChar char="•"/>
             </a:pPr>
@@ -5612,7 +5612,24 @@
                 </a:solidFill>
                 <a:latin typeface="Segoe UI"/>
               </a:rPr>
-              <a:t>The grid orders what Comparison 2 tests first; under proposed OD-34, the pilot decides what scales</a:t>
+              <a:t>All 48 role answers re-run on the reframe: six tightened controls, every verdict held</a:t>
+            </a:r>
+          </a:p>
+          <a:p>
+            <a:pPr algn="l" marL="228600" indent="-228600">
+              <a:spcAft>
+                <a:spcPts val="800"/>
+              </a:spcAft>
+              <a:buChar char="•"/>
+            </a:pPr>
+            <a:r>
+              <a:rPr sz="1400" b="0" i="0">
+                <a:solidFill>
+                  <a:srgbClr val="243B53"/>
+                </a:solidFill>
+                <a:latin typeface="Segoe UI"/>
+              </a:rPr>
+              <a:t>The grid orders Comparison 2 tests; under proposed OD-34, the pilot decides what scales</a:t>
             </a:r>
           </a:p>
         </p:txBody>
@@ -5702,7 +5719,7 @@
                 </a:solidFill>
                 <a:latin typeface="Segoe UI"/>
               </a:rPr>
-              <a:t>Sources: agent-what-if-study.md (Reconciliation With the Current Proposal; Value vs Complexity Quadrant) and its post-merge review, 27 Sep 2026. Scores are coarse judgements; role answers are hypotheses.</a:t>
+              <a:t>Sources: agent-what-if-study.md (Reconciliation; Value vs Complexity Quadrant), post-merge review and role-answer re-run, 27 Sep 2026. Scores are coarse judgements; role answers are hypotheses.</a:t>
             </a:r>
           </a:p>
         </p:txBody>
@@ -10160,7 +10177,7 @@
                 </a:solidFill>
                 <a:latin typeface="Segoe UI"/>
               </a:rPr>
-              <a:t>39 commits, 10 to 27 Sep, and PR #1; most messages say what changed and why</a:t>
+              <a:t>41 commits, 10 to 27 Sep, and three merged PRs; the log records what changed and why</a:t>
             </a:r>
           </a:p>
         </p:txBody>
@@ -11650,7 +11667,7 @@
                 </a:solidFill>
                 <a:latin typeface="Segoe UI"/>
               </a:rPr>
-              <a:t>Sources: git log (39 commits, 10 to 27 Sep 2026); docs/reference/log.md; docs/brds/agentic-retrofit-programme-brd.md history.</a:t>
+              <a:t>Sources: git log (41 commits, 10 to 27 Sep 2026); docs/reference/log.md; docs/brds/agentic-retrofit-programme-brd.md history.</a:t>
             </a:r>
           </a:p>
         </p:txBody>

</xml_diff>

<commit_message>
Update AMA Mentor Progress Review Deck for Iteration 6
- Adjusted source footers for slides 3 to 13 to improve alignment and visibility.
- Updated Git commit count to 42 non-merge commits through 27 September on slides 3 and 15.
- Clarified merged pull request count on slide 15, distinguishing between research period and later merges.
- Revised speaker notes and content for clarity and conciseness across multiple slides.
- Added new documentation for storytelling review findings and validation results.
- Updated knowledge base log and README to reflect changes and publication status.
- Ensured all validators report zero issues across the 15-slide deck.
</commit_message>
<xml_diff>
--- a/.copilot-tracking/ppt/2026-09-26/ama-mentor-progress-review/slide-deck/ama-mentor-progress-review.pptx
+++ b/.copilot-tracking/ppt/2026-09-26/ama-mentor-progress-review/slide-deck/ama-mentor-progress-review.pptx
@@ -5698,8 +5698,8 @@
         </p:nvSpPr>
         <p:spPr>
           <a:xfrm>
-            <a:off x="548640" y="6126480"/>
-            <a:ext cx="11094415" cy="256032"/>
+            <a:off x="548640" y="6035040"/>
+            <a:ext cx="10972800" cy="347472"/>
           </a:xfrm>
           <a:prstGeom prst="rect">
             <a:avLst/>
@@ -5707,11 +5707,12 @@
           <a:noFill/>
         </p:spPr>
         <p:txBody>
-          <a:bodyPr wrap="square" tIns="0" bIns="0">
+          <a:bodyPr wrap="square" lIns="0" rIns="0" tIns="0" bIns="0" anchor="t">
             <a:spAutoFit/>
           </a:bodyPr>
           <a:lstStyle/>
           <a:p>
+            <a:pPr algn="l"/>
             <a:r>
               <a:rPr sz="900" b="0" i="0">
                 <a:solidFill>
@@ -5719,7 +5720,19 @@
                 </a:solidFill>
                 <a:latin typeface="Segoe UI"/>
               </a:rPr>
-              <a:t>Sources: agent-what-if-study.md (Reconciliation; Value vs Complexity Quadrant), post-merge review and role-answer re-run, 27 Sep 2026. Scores are coarse judgements; role answers are hypotheses.</a:t>
+              <a:t>Sources: Agent What-If Study (Reconciliation; Value vs Complexity), post-merge review and role-answer re-run, 27 Sep 2026.</a:t>
+            </a:r>
+          </a:p>
+          <a:p>
+            <a:pPr algn="l"/>
+            <a:r>
+              <a:rPr sz="900" b="0" i="0">
+                <a:solidFill>
+                  <a:srgbClr val="627D98"/>
+                </a:solidFill>
+                <a:latin typeface="Segoe UI"/>
+              </a:rPr>
+              <a:t>Scores are coarse judgements; role answers are hypotheses.</a:t>
             </a:r>
           </a:p>
         </p:txBody>
@@ -6685,8 +6698,8 @@
         </p:nvSpPr>
         <p:spPr>
           <a:xfrm>
-            <a:off x="548640" y="6126480"/>
-            <a:ext cx="11094415" cy="256032"/>
+            <a:off x="548640" y="6035040"/>
+            <a:ext cx="10972800" cy="347472"/>
           </a:xfrm>
           <a:prstGeom prst="rect">
             <a:avLst/>
@@ -6694,11 +6707,12 @@
           <a:noFill/>
         </p:spPr>
         <p:txBody>
-          <a:bodyPr wrap="square" tIns="0" bIns="0">
+          <a:bodyPr wrap="square" lIns="0" rIns="0" tIns="0" bIns="0" anchor="t">
             <a:spAutoFit/>
           </a:bodyPr>
           <a:lstStyle/>
           <a:p>
+            <a:pPr algn="l"/>
             <a:r>
               <a:rPr sz="900" b="0" i="0">
                 <a:solidFill>
@@ -6706,7 +6720,19 @@
                 </a:solidFill>
                 <a:latin typeface="Segoe UI"/>
               </a:rPr>
-              <a:t>Sources: BRD v0.5.0 frontmatter and Requirements Traceability; .copilot-tracking/brd-sessions/agentic-retrofit-programme.quality-report.yml (Runs 1 to 6); log.md (26 Sep 2026).</a:t>
+              <a:t>Sources: BRD v0.5.0 frontmatter and Requirements Traceability; BRD quality report, runs 1 to 6;</a:t>
+            </a:r>
+          </a:p>
+          <a:p>
+            <a:pPr algn="l"/>
+            <a:r>
+              <a:rPr sz="900" b="0" i="0">
+                <a:solidFill>
+                  <a:srgbClr val="627D98"/>
+                </a:solidFill>
+                <a:latin typeface="Segoe UI"/>
+              </a:rPr>
+              <a:t>log, 26 Sep 2026.</a:t>
             </a:r>
           </a:p>
         </p:txBody>
@@ -7303,8 +7329,8 @@
         </p:nvSpPr>
         <p:spPr>
           <a:xfrm>
-            <a:off x="548640" y="6126480"/>
-            <a:ext cx="11094415" cy="256032"/>
+            <a:off x="548640" y="6035040"/>
+            <a:ext cx="10972800" cy="347472"/>
           </a:xfrm>
           <a:prstGeom prst="rect">
             <a:avLst/>
@@ -7312,11 +7338,12 @@
           <a:noFill/>
         </p:spPr>
         <p:txBody>
-          <a:bodyPr wrap="square" tIns="0" bIns="0">
+          <a:bodyPr wrap="square" lIns="0" rIns="0" tIns="0" bIns="0" anchor="t">
             <a:spAutoFit/>
           </a:bodyPr>
           <a:lstStyle/>
           <a:p>
+            <a:pPr algn="l"/>
             <a:r>
               <a:rPr sz="900" b="0" i="0">
                 <a:solidFill>
@@ -7324,7 +7351,7 @@
                 </a:solidFill>
                 <a:latin typeface="Segoe UI"/>
               </a:rPr>
-              <a:t>Sources: docs/reference/log.md (Conventions; corrections, 25 to 26 Sep 2026); agent-request-challenge.md (Divergences, Limitations); git log.</a:t>
+              <a:t>Sources: knowledge-base log (conventions and corrections, 25 to 26 Sep 2026); Agent Request Challenge (Divergences; Limitations); git log.</a:t>
             </a:r>
           </a:p>
         </p:txBody>
@@ -8567,8 +8594,8 @@
         </p:nvSpPr>
         <p:spPr>
           <a:xfrm>
-            <a:off x="548640" y="6126480"/>
-            <a:ext cx="11094415" cy="256032"/>
+            <a:off x="548640" y="6035040"/>
+            <a:ext cx="10972800" cy="347472"/>
           </a:xfrm>
           <a:prstGeom prst="rect">
             <a:avLst/>
@@ -8576,11 +8603,12 @@
           <a:noFill/>
         </p:spPr>
         <p:txBody>
-          <a:bodyPr wrap="square" tIns="0" bIns="0">
+          <a:bodyPr wrap="square" lIns="0" rIns="0" tIns="0" bIns="0" anchor="t">
             <a:spAutoFit/>
           </a:bodyPr>
           <a:lstStyle/>
           <a:p>
+            <a:pPr algn="l"/>
             <a:r>
               <a:rPr sz="900" b="0" i="0">
                 <a:solidFill>
@@ -8588,7 +8616,19 @@
                 </a:solidFill>
                 <a:latin typeface="Segoe UI"/>
               </a:rPr>
-              <a:t>Sources: case_study_48_addendum.md (Recommended Executive Decision); agent-request-challenge.md; BRD FR-026, CON-005; WH:SHF annex snapshot; log.md.</a:t>
+              <a:t>Sources: addendum (Recommended Executive Decision); Agent Request Challenge; BRD FR-026 and CON-005;</a:t>
+            </a:r>
+          </a:p>
+          <a:p>
+            <a:pPr algn="l"/>
+            <a:r>
+              <a:rPr sz="900" b="0" i="0">
+                <a:solidFill>
+                  <a:srgbClr val="627D98"/>
+                </a:solidFill>
+                <a:latin typeface="Segoe UI"/>
+              </a:rPr>
+              <a:t>WH:SHF annex snapshot; knowledge-base log.</a:t>
             </a:r>
           </a:p>
         </p:txBody>
@@ -10177,7 +10217,7 @@
                 </a:solidFill>
                 <a:latin typeface="Segoe UI"/>
               </a:rPr>
-              <a:t>41 commits, 10 to 27 Sep, and three merged PRs; the log records what changed and why</a:t>
+              <a:t>42 non-merge commits, 10 to 27 Sep, and five merged PRs by 28 Sep; the log records what changed and why</a:t>
             </a:r>
           </a:p>
         </p:txBody>
@@ -11646,8 +11686,8 @@
         </p:nvSpPr>
         <p:spPr>
           <a:xfrm>
-            <a:off x="548640" y="6126480"/>
-            <a:ext cx="11094415" cy="256032"/>
+            <a:off x="548640" y="6035040"/>
+            <a:ext cx="10972800" cy="347472"/>
           </a:xfrm>
           <a:prstGeom prst="rect">
             <a:avLst/>
@@ -11655,11 +11695,12 @@
           <a:noFill/>
         </p:spPr>
         <p:txBody>
-          <a:bodyPr wrap="square" tIns="0" bIns="0">
+          <a:bodyPr wrap="square" lIns="0" rIns="0" tIns="0" bIns="0" anchor="t">
             <a:spAutoFit/>
           </a:bodyPr>
           <a:lstStyle/>
           <a:p>
+            <a:pPr algn="l"/>
             <a:r>
               <a:rPr sz="900" b="0" i="0">
                 <a:solidFill>
@@ -11667,7 +11708,7 @@
                 </a:solidFill>
                 <a:latin typeface="Segoe UI"/>
               </a:rPr>
-              <a:t>Sources: git log (41 commits, 10 to 27 Sep 2026); docs/reference/log.md; docs/brds/agentic-retrofit-programme-brd.md history.</a:t>
+              <a:t>Sources: git log (42 non-merge commits, 10 to 27 Sep 2026); docs/reference/log.md; BRD history.</a:t>
             </a:r>
           </a:p>
         </p:txBody>
@@ -12249,8 +12290,8 @@
         </p:nvSpPr>
         <p:spPr>
           <a:xfrm>
-            <a:off x="548640" y="6126480"/>
-            <a:ext cx="11094415" cy="256032"/>
+            <a:off x="548640" y="6035040"/>
+            <a:ext cx="10972800" cy="347472"/>
           </a:xfrm>
           <a:prstGeom prst="rect">
             <a:avLst/>
@@ -12258,11 +12299,12 @@
           <a:noFill/>
         </p:spPr>
         <p:txBody>
-          <a:bodyPr wrap="square" tIns="0" bIns="0">
+          <a:bodyPr wrap="square" lIns="0" rIns="0" tIns="0" bIns="0" anchor="t">
             <a:spAutoFit/>
           </a:bodyPr>
           <a:lstStyle/>
           <a:p>
+            <a:pPr algn="l"/>
             <a:r>
               <a:rPr sz="900" b="0" i="0">
                 <a:solidFill>
@@ -12270,7 +12312,19 @@
                 </a:solidFill>
                 <a:latin typeface="Segoe UI"/>
               </a:rPr>
-              <a:t>Sources: company-profile-research.md; housing-association-primer.md; uk-social-housing-baseline-research.md; regulatory/README.md. Benchmarks are not company facts.</a:t>
+              <a:t>Sources: company profile; housing association primer; UK social housing baseline; regulatory register.</a:t>
+            </a:r>
+          </a:p>
+          <a:p>
+            <a:pPr algn="l"/>
+            <a:r>
+              <a:rPr sz="900" b="0" i="0">
+                <a:solidFill>
+                  <a:srgbClr val="627D98"/>
+                </a:solidFill>
+                <a:latin typeface="Segoe UI"/>
+              </a:rPr>
+              <a:t>Benchmarks are not company facts.</a:t>
             </a:r>
           </a:p>
         </p:txBody>
@@ -13392,8 +13446,8 @@
         </p:nvSpPr>
         <p:spPr>
           <a:xfrm>
-            <a:off x="548640" y="6126480"/>
-            <a:ext cx="11094415" cy="256032"/>
+            <a:off x="548640" y="6035040"/>
+            <a:ext cx="10972800" cy="347472"/>
           </a:xfrm>
           <a:prstGeom prst="rect">
             <a:avLst/>
@@ -13401,11 +13455,12 @@
           <a:noFill/>
         </p:spPr>
         <p:txBody>
-          <a:bodyPr wrap="square" tIns="0" bIns="0">
+          <a:bodyPr wrap="square" lIns="0" rIns="0" tIns="0" bIns="0" anchor="t">
             <a:spAutoFit/>
           </a:bodyPr>
           <a:lstStyle/>
           <a:p>
+            <a:pPr algn="l"/>
             <a:r>
               <a:rPr sz="900" b="0" i="0">
                 <a:solidFill>
@@ -13413,7 +13468,19 @@
                 </a:solidFill>
                 <a:latin typeface="Segoe UI"/>
               </a:rPr>
-              <a:t>Sources: .github/agents/company-*.agent.md; agent-request-challenge.md (Grant and Funding); WH:SHF technical annex (Page 3, Page 5 Table 3), retrieved 19 Sep 2026. Question paraphrased.</a:t>
+              <a:t>Sources: company role agents; Agent Request Challenge (Grant and Funding); WH:SHF technical annex, pp. 3 and 5 (retrieved 19 Sep 2026).</a:t>
+            </a:r>
+          </a:p>
+          <a:p>
+            <a:pPr algn="l"/>
+            <a:r>
+              <a:rPr sz="900" b="0" i="0">
+                <a:solidFill>
+                  <a:srgbClr val="627D98"/>
+                </a:solidFill>
+                <a:latin typeface="Segoe UI"/>
+              </a:rPr>
+              <a:t>Question paraphrased.</a:t>
             </a:r>
           </a:p>
         </p:txBody>
@@ -14212,8 +14279,8 @@
         </p:nvSpPr>
         <p:spPr>
           <a:xfrm>
-            <a:off x="548640" y="6126480"/>
-            <a:ext cx="11094415" cy="256032"/>
+            <a:off x="548640" y="6035040"/>
+            <a:ext cx="10972800" cy="347472"/>
           </a:xfrm>
           <a:prstGeom prst="rect">
             <a:avLst/>
@@ -14221,11 +14288,12 @@
           <a:noFill/>
         </p:spPr>
         <p:txBody>
-          <a:bodyPr wrap="square" tIns="0" bIns="0">
+          <a:bodyPr wrap="square" lIns="0" rIns="0" tIns="0" bIns="0" anchor="t">
             <a:spAutoFit/>
           </a:bodyPr>
           <a:lstStyle/>
           <a:p>
+            <a:pPr algn="l"/>
             <a:r>
               <a:rPr sz="900" b="0" i="0">
                 <a:solidFill>
@@ -15082,8 +15150,8 @@
         </p:nvSpPr>
         <p:spPr>
           <a:xfrm>
-            <a:off x="548640" y="6126480"/>
-            <a:ext cx="11094415" cy="256032"/>
+            <a:off x="548640" y="6035040"/>
+            <a:ext cx="10972800" cy="347472"/>
           </a:xfrm>
           <a:prstGeom prst="rect">
             <a:avLst/>
@@ -15091,11 +15159,12 @@
           <a:noFill/>
         </p:spPr>
         <p:txBody>
-          <a:bodyPr wrap="square" tIns="0" bIns="0">
+          <a:bodyPr wrap="square" lIns="0" rIns="0" tIns="0" bIns="0" anchor="t">
             <a:spAutoFit/>
           </a:bodyPr>
           <a:lstStyle/>
           <a:p>
+            <a:pPr algn="l"/>
             <a:r>
               <a:rPr sz="900" b="0" i="0">
                 <a:solidFill>
@@ -15103,7 +15172,19 @@
                 </a:solidFill>
                 <a:latin typeface="Segoe UI"/>
               </a:rPr>
-              <a:t>Source: agent-request-challenge.md (26 Sep 2026). Roles read the case, addendum and BRD: verdicts are sector-informed hypotheses, not validation.</a:t>
+              <a:t>Source: Agent Request Challenge (26 Sep 2026). Roles read the case, addendum and BRD.</a:t>
+            </a:r>
+          </a:p>
+          <a:p>
+            <a:pPr algn="l"/>
+            <a:r>
+              <a:rPr sz="900" b="0" i="0">
+                <a:solidFill>
+                  <a:srgbClr val="627D98"/>
+                </a:solidFill>
+                <a:latin typeface="Segoe UI"/>
+              </a:rPr>
+              <a:t>Verdicts are sector-informed hypotheses, not validation.</a:t>
             </a:r>
           </a:p>
         </p:txBody>
@@ -15738,8 +15819,8 @@
         </p:nvSpPr>
         <p:spPr>
           <a:xfrm>
-            <a:off x="548640" y="6126480"/>
-            <a:ext cx="11094415" cy="256032"/>
+            <a:off x="548640" y="6035040"/>
+            <a:ext cx="10972800" cy="347472"/>
           </a:xfrm>
           <a:prstGeom prst="rect">
             <a:avLst/>
@@ -15747,11 +15828,12 @@
           <a:noFill/>
         </p:spPr>
         <p:txBody>
-          <a:bodyPr wrap="square" tIns="0" bIns="0">
+          <a:bodyPr wrap="square" lIns="0" rIns="0" tIns="0" bIns="0" anchor="t">
             <a:spAutoFit/>
           </a:bodyPr>
           <a:lstStyle/>
           <a:p>
+            <a:pPr algn="l"/>
             <a:r>
               <a:rPr sz="900" b="0" i="0">
                 <a:solidFill>
@@ -15759,7 +15841,19 @@
                 </a:solidFill>
                 <a:latin typeface="Segoe UI"/>
               </a:rPr>
-              <a:t>Sources: case_study_48_addendum.md (Where Agents Fit; Agentic Architecture Brief); agent-request-challenge.md; BRD v0.5.0 Document Status (owner decision, 26 Sep 2026).</a:t>
+              <a:t>Sources: addendum (Where Agents Fit; Agentic Architecture Brief); Agent Request Challenge;</a:t>
+            </a:r>
+          </a:p>
+          <a:p>
+            <a:pPr algn="l"/>
+            <a:r>
+              <a:rPr sz="900" b="0" i="0">
+                <a:solidFill>
+                  <a:srgbClr val="627D98"/>
+                </a:solidFill>
+                <a:latin typeface="Segoe UI"/>
+              </a:rPr>
+              <a:t>BRD v0.5.0 Document Status (owner decision, 26 Sep 2026).</a:t>
             </a:r>
           </a:p>
         </p:txBody>
@@ -16144,8 +16238,8 @@
         </p:nvSpPr>
         <p:spPr>
           <a:xfrm>
-            <a:off x="548640" y="6126480"/>
-            <a:ext cx="11094415" cy="256032"/>
+            <a:off x="548640" y="6035040"/>
+            <a:ext cx="10972800" cy="347472"/>
           </a:xfrm>
           <a:prstGeom prst="rect">
             <a:avLst/>
@@ -16153,11 +16247,12 @@
           <a:noFill/>
         </p:spPr>
         <p:txBody>
-          <a:bodyPr wrap="square" tIns="0" bIns="0">
+          <a:bodyPr wrap="square" lIns="0" rIns="0" tIns="0" bIns="0" anchor="t">
             <a:spAutoFit/>
           </a:bodyPr>
           <a:lstStyle/>
           <a:p>
+            <a:pPr algn="l"/>
             <a:r>
               <a:rPr sz="900" b="0" i="0">
                 <a:solidFill>
@@ -16165,7 +16260,19 @@
                 </a:solidFill>
                 <a:latin typeface="Segoe UI"/>
               </a:rPr>
-              <a:t>Sources: pilot-measurement-challenge.md (Summary; Owner Decision); BRD v0.5.0 CON-003, RULE-019, RULE-024, AC-079, FR-042 to FR-044, OD-34, OD-39; log.md (26 Sep 2026). Role answers are hypotheses.</a:t>
+              <a:t>Sources: Pilot Measurement Challenge; BRD v0.5.0 CON-003, RULE-019, RULE-024, AC-079, FR-042 to FR-044, OD-34 and OD-39;</a:t>
+            </a:r>
+          </a:p>
+          <a:p>
+            <a:pPr algn="l"/>
+            <a:r>
+              <a:rPr sz="900" b="0" i="0">
+                <a:solidFill>
+                  <a:srgbClr val="627D98"/>
+                </a:solidFill>
+                <a:latin typeface="Segoe UI"/>
+              </a:rPr>
+              <a:t>log, 26 Sep 2026. Role answers are hypotheses.</a:t>
             </a:r>
           </a:p>
         </p:txBody>

</xml_diff>

<commit_message>
feat: rename the exercise to Zava North Homes and Zava Forward
Migrate active documentation, Python packages, runtime contracts, infrastructure defaults, presentation text/source and website logos. Keep exact historical snapshots for incoming evidence links. Document the remaining Entra provisioning blocker.

Co-authored-by: Copilot <223556219+Copilot@users.noreply.github.com>
</commit_message>
<xml_diff>
--- a/.copilot-tracking/ppt/2026-09-26/ama-mentor-progress-review/slide-deck/ama-mentor-progress-review.pptx
+++ b/.copilot-tracking/ppt/2026-09-26/ama-mentor-progress-review/slide-deck/ama-mentor-progress-review.pptx
@@ -499,6 +499,10 @@
           </p:nvPr>
         </p:nvSpPr>
         <p:spPr/>
+        <p:txBody>
+          <a:bodyPr/>
+          <a:p/>
+        </p:txBody>
       </p:sp>
       <p:sp>
         <p:nvSpPr>
@@ -538,6 +542,10 @@
           </p:nvPr>
         </p:nvSpPr>
         <p:spPr/>
+        <p:txBody>
+          <a:bodyPr/>
+          <a:p/>
+        </p:txBody>
       </p:sp>
     </p:spTree>
   </p:cSld>
@@ -575,6 +583,10 @@
           </p:nvPr>
         </p:nvSpPr>
         <p:spPr/>
+        <p:txBody>
+          <a:bodyPr/>
+          <a:p/>
+        </p:txBody>
       </p:sp>
       <p:sp>
         <p:nvSpPr>
@@ -626,6 +638,10 @@
           </p:nvPr>
         </p:nvSpPr>
         <p:spPr/>
+        <p:txBody>
+          <a:bodyPr/>
+          <a:p/>
+        </p:txBody>
       </p:sp>
     </p:spTree>
   </p:cSld>
@@ -663,6 +679,10 @@
           </p:nvPr>
         </p:nvSpPr>
         <p:spPr/>
+        <p:txBody>
+          <a:bodyPr/>
+          <a:p/>
+        </p:txBody>
       </p:sp>
       <p:sp>
         <p:nvSpPr>
@@ -708,6 +728,10 @@
           </p:nvPr>
         </p:nvSpPr>
         <p:spPr/>
+        <p:txBody>
+          <a:bodyPr/>
+          <a:p/>
+        </p:txBody>
       </p:sp>
     </p:spTree>
   </p:cSld>
@@ -745,6 +769,10 @@
           </p:nvPr>
         </p:nvSpPr>
         <p:spPr/>
+        <p:txBody>
+          <a:bodyPr/>
+          <a:p/>
+        </p:txBody>
       </p:sp>
       <p:sp>
         <p:nvSpPr>
@@ -790,6 +818,10 @@
           </p:nvPr>
         </p:nvSpPr>
         <p:spPr/>
+        <p:txBody>
+          <a:bodyPr/>
+          <a:p/>
+        </p:txBody>
       </p:sp>
     </p:spTree>
   </p:cSld>
@@ -827,6 +859,10 @@
           </p:nvPr>
         </p:nvSpPr>
         <p:spPr/>
+        <p:txBody>
+          <a:bodyPr/>
+          <a:p/>
+        </p:txBody>
       </p:sp>
       <p:sp>
         <p:nvSpPr>
@@ -872,6 +908,10 @@
           </p:nvPr>
         </p:nvSpPr>
         <p:spPr/>
+        <p:txBody>
+          <a:bodyPr/>
+          <a:p/>
+        </p:txBody>
       </p:sp>
     </p:spTree>
   </p:cSld>
@@ -909,6 +949,10 @@
           </p:nvPr>
         </p:nvSpPr>
         <p:spPr/>
+        <p:txBody>
+          <a:bodyPr/>
+          <a:p/>
+        </p:txBody>
       </p:sp>
       <p:sp>
         <p:nvSpPr>
@@ -978,6 +1022,10 @@
           </p:nvPr>
         </p:nvSpPr>
         <p:spPr/>
+        <p:txBody>
+          <a:bodyPr/>
+          <a:p/>
+        </p:txBody>
       </p:sp>
     </p:spTree>
   </p:cSld>
@@ -1015,6 +1063,10 @@
           </p:nvPr>
         </p:nvSpPr>
         <p:spPr/>
+        <p:txBody>
+          <a:bodyPr/>
+          <a:p/>
+        </p:txBody>
       </p:sp>
       <p:sp>
         <p:nvSpPr>
@@ -1117,6 +1169,10 @@
           </p:nvPr>
         </p:nvSpPr>
         <p:spPr/>
+        <p:txBody>
+          <a:bodyPr/>
+          <a:p/>
+        </p:txBody>
       </p:sp>
     </p:spTree>
   </p:cSld>
@@ -1154,6 +1210,10 @@
           </p:nvPr>
         </p:nvSpPr>
         <p:spPr/>
+        <p:txBody>
+          <a:bodyPr/>
+          <a:p/>
+        </p:txBody>
       </p:sp>
       <p:sp>
         <p:nvSpPr>
@@ -1229,6 +1289,10 @@
           </p:nvPr>
         </p:nvSpPr>
         <p:spPr/>
+        <p:txBody>
+          <a:bodyPr/>
+          <a:p/>
+        </p:txBody>
       </p:sp>
     </p:spTree>
   </p:cSld>
@@ -1266,6 +1330,10 @@
           </p:nvPr>
         </p:nvSpPr>
         <p:spPr/>
+        <p:txBody>
+          <a:bodyPr/>
+          <a:p/>
+        </p:txBody>
       </p:sp>
       <p:sp>
         <p:nvSpPr>
@@ -1311,6 +1379,10 @@
           </p:nvPr>
         </p:nvSpPr>
         <p:spPr/>
+        <p:txBody>
+          <a:bodyPr/>
+          <a:p/>
+        </p:txBody>
       </p:sp>
     </p:spTree>
   </p:cSld>
@@ -1348,6 +1420,10 @@
           </p:nvPr>
         </p:nvSpPr>
         <p:spPr/>
+        <p:txBody>
+          <a:bodyPr/>
+          <a:p/>
+        </p:txBody>
       </p:sp>
       <p:sp>
         <p:nvSpPr>
@@ -1405,6 +1481,10 @@
           </p:nvPr>
         </p:nvSpPr>
         <p:spPr/>
+        <p:txBody>
+          <a:bodyPr/>
+          <a:p/>
+        </p:txBody>
       </p:sp>
     </p:spTree>
   </p:cSld>
@@ -1442,6 +1522,10 @@
           </p:nvPr>
         </p:nvSpPr>
         <p:spPr/>
+        <p:txBody>
+          <a:bodyPr/>
+          <a:p/>
+        </p:txBody>
       </p:sp>
       <p:sp>
         <p:nvSpPr>
@@ -1471,7 +1555,7 @@
           <a:p/>
           <a:p>
             <a:r>
-              <a:t>One exchange: would a grant-drafting agent add value? The finance role answered with a fact from the local snapshot: in Greater Manchester and the West Midlands, Wave 3 money is allocated by formula, not by bid. Whether Proper North Homes operates there is unknown. So the BRD now requires an evidenced funding route before any bid work starts.</a:t>
+              <a:t>One exchange: would a grant-drafting agent add value? The finance role answered with a fact from the local snapshot: in Greater Manchester and the West Midlands, Wave 3 money is allocated by formula, not by bid. Whether Zava North Homes operates there is unknown. So the BRD now requires an evidenced funding route before any bid work starts.</a:t>
             </a:r>
           </a:p>
         </p:txBody>
@@ -1487,6 +1571,10 @@
           </p:nvPr>
         </p:nvSpPr>
         <p:spPr/>
+        <p:txBody>
+          <a:bodyPr/>
+          <a:p/>
+        </p:txBody>
       </p:sp>
     </p:spTree>
   </p:cSld>
@@ -1524,6 +1612,10 @@
           </p:nvPr>
         </p:nvSpPr>
         <p:spPr/>
+        <p:txBody>
+          <a:bodyPr/>
+          <a:p/>
+        </p:txBody>
       </p:sp>
       <p:sp>
         <p:nvSpPr>
@@ -1569,6 +1661,10 @@
           </p:nvPr>
         </p:nvSpPr>
         <p:spPr/>
+        <p:txBody>
+          <a:bodyPr/>
+          <a:p/>
+        </p:txBody>
       </p:sp>
     </p:spTree>
   </p:cSld>
@@ -1606,6 +1702,10 @@
           </p:nvPr>
         </p:nvSpPr>
         <p:spPr/>
+        <p:txBody>
+          <a:bodyPr/>
+          <a:p/>
+        </p:txBody>
       </p:sp>
       <p:sp>
         <p:nvSpPr>
@@ -1657,6 +1757,10 @@
           </p:nvPr>
         </p:nvSpPr>
         <p:spPr/>
+        <p:txBody>
+          <a:bodyPr/>
+          <a:p/>
+        </p:txBody>
       </p:sp>
     </p:spTree>
   </p:cSld>
@@ -1694,6 +1798,10 @@
           </p:nvPr>
         </p:nvSpPr>
         <p:spPr/>
+        <p:txBody>
+          <a:bodyPr/>
+          <a:p/>
+        </p:txBody>
       </p:sp>
       <p:sp>
         <p:nvSpPr>
@@ -1739,6 +1847,10 @@
           </p:nvPr>
         </p:nvSpPr>
         <p:spPr/>
+        <p:txBody>
+          <a:bodyPr/>
+          <a:p/>
+        </p:txBody>
       </p:sp>
     </p:spTree>
   </p:cSld>
@@ -1776,6 +1888,10 @@
           </p:nvPr>
         </p:nvSpPr>
         <p:spPr/>
+        <p:txBody>
+          <a:bodyPr/>
+          <a:p/>
+        </p:txBody>
       </p:sp>
       <p:sp>
         <p:nvSpPr>
@@ -1827,6 +1943,10 @@
           </p:nvPr>
         </p:nvSpPr>
         <p:spPr/>
+        <p:txBody>
+          <a:bodyPr/>
+          <a:p/>
+        </p:txBody>
       </p:sp>
     </p:spTree>
   </p:cSld>
@@ -4933,7 +5053,7 @@
                 </a:solidFill>
                 <a:latin typeface="Segoe UI"/>
               </a:rPr>
-              <a:t>How I filled the gaps in the Proper Warm case, 10 to 27 September 2026</a:t>
+              <a:t>How I filled the gaps in the Zava Forward case, 10 to 27 September 2026</a:t>
             </a:r>
           </a:p>
         </p:txBody>
@@ -5017,6 +5137,73 @@
           </a:p>
         </p:txBody>
       </p:sp>
+      <p:sp>
+        <p:nvSpPr>
+          <p:cNvPr id="7" name="Zava logo contrast backing"/>
+          <p:cNvSpPr/>
+          <p:nvPr/>
+        </p:nvSpPr>
+        <p:spPr>
+          <a:xfrm>
+            <a:off x="11048695" y="109728"/>
+            <a:ext cx="960120" cy="335445"/>
+          </a:xfrm>
+          <a:prstGeom prst="rect">
+            <a:avLst/>
+          </a:prstGeom>
+          <a:solidFill>
+            <a:srgbClr val="FFFFFF"/>
+          </a:solidFill>
+          <a:ln>
+            <a:noFill/>
+          </a:ln>
+        </p:spPr>
+        <p:style>
+          <a:lnRef idx="1">
+            <a:schemeClr val="accent1"/>
+          </a:lnRef>
+          <a:fillRef idx="3">
+            <a:schemeClr val="accent1"/>
+          </a:fillRef>
+          <a:effectRef idx="2">
+            <a:schemeClr val="accent1"/>
+          </a:effectRef>
+          <a:fontRef idx="minor">
+            <a:schemeClr val="lt1"/>
+          </a:fontRef>
+        </p:style>
+        <p:txBody>
+          <a:bodyPr rtlCol="0" anchor="ctr"/>
+          <a:lstStyle/>
+          <a:p>
+            <a:pPr algn="ctr"/>
+          </a:p>
+        </p:txBody>
+      </p:sp>
+      <p:pic>
+        <p:nvPicPr>
+          <p:cNvPr id="8" name="Zava branding logo" descr="image.png"/>
+          <p:cNvPicPr>
+            <a:picLocks noChangeAspect="1"/>
+          </p:cNvPicPr>
+          <p:nvPr/>
+        </p:nvPicPr>
+        <p:blipFill>
+          <a:blip r:embed="rId3"/>
+          <a:stretch>
+            <a:fillRect/>
+          </a:stretch>
+        </p:blipFill>
+        <p:spPr>
+          <a:xfrm>
+            <a:off x="11048695" y="109728"/>
+            <a:ext cx="960120" cy="335446"/>
+          </a:xfrm>
+          <a:prstGeom prst="rect">
+            <a:avLst/>
+          </a:prstGeom>
+        </p:spPr>
+      </p:pic>
     </p:spTree>
   </p:cSld>
   <p:clrMapOvr>
@@ -5737,6 +5924,73 @@
           </a:p>
         </p:txBody>
       </p:sp>
+      <p:sp>
+        <p:nvSpPr>
+          <p:cNvPr id="8" name="Zava logo contrast backing"/>
+          <p:cNvSpPr/>
+          <p:nvPr/>
+        </p:nvSpPr>
+        <p:spPr>
+          <a:xfrm>
+            <a:off x="11048695" y="109728"/>
+            <a:ext cx="960120" cy="335445"/>
+          </a:xfrm>
+          <a:prstGeom prst="rect">
+            <a:avLst/>
+          </a:prstGeom>
+          <a:solidFill>
+            <a:srgbClr val="FFFFFF"/>
+          </a:solidFill>
+          <a:ln>
+            <a:noFill/>
+          </a:ln>
+        </p:spPr>
+        <p:style>
+          <a:lnRef idx="1">
+            <a:schemeClr val="accent1"/>
+          </a:lnRef>
+          <a:fillRef idx="3">
+            <a:schemeClr val="accent1"/>
+          </a:fillRef>
+          <a:effectRef idx="2">
+            <a:schemeClr val="accent1"/>
+          </a:effectRef>
+          <a:fontRef idx="minor">
+            <a:schemeClr val="lt1"/>
+          </a:fontRef>
+        </p:style>
+        <p:txBody>
+          <a:bodyPr rtlCol="0" anchor="ctr"/>
+          <a:lstStyle/>
+          <a:p>
+            <a:pPr algn="ctr"/>
+          </a:p>
+        </p:txBody>
+      </p:sp>
+      <p:pic>
+        <p:nvPicPr>
+          <p:cNvPr id="9" name="Zava branding logo" descr="image.png"/>
+          <p:cNvPicPr>
+            <a:picLocks noChangeAspect="1"/>
+          </p:cNvPicPr>
+          <p:nvPr/>
+        </p:nvPicPr>
+        <p:blipFill>
+          <a:blip r:embed="rId3"/>
+          <a:stretch>
+            <a:fillRect/>
+          </a:stretch>
+        </p:blipFill>
+        <p:spPr>
+          <a:xfrm>
+            <a:off x="11048695" y="109728"/>
+            <a:ext cx="960120" cy="335446"/>
+          </a:xfrm>
+          <a:prstGeom prst="rect">
+            <a:avLst/>
+          </a:prstGeom>
+        </p:spPr>
+      </p:pic>
     </p:spTree>
   </p:cSld>
   <p:clrMapOvr>
@@ -6737,6 +6991,73 @@
           </a:p>
         </p:txBody>
       </p:sp>
+      <p:sp>
+        <p:nvSpPr>
+          <p:cNvPr id="21" name="Zava logo contrast backing"/>
+          <p:cNvSpPr/>
+          <p:nvPr/>
+        </p:nvSpPr>
+        <p:spPr>
+          <a:xfrm>
+            <a:off x="11048695" y="109728"/>
+            <a:ext cx="960120" cy="335445"/>
+          </a:xfrm>
+          <a:prstGeom prst="rect">
+            <a:avLst/>
+          </a:prstGeom>
+          <a:solidFill>
+            <a:srgbClr val="FFFFFF"/>
+          </a:solidFill>
+          <a:ln>
+            <a:noFill/>
+          </a:ln>
+        </p:spPr>
+        <p:style>
+          <a:lnRef idx="1">
+            <a:schemeClr val="accent1"/>
+          </a:lnRef>
+          <a:fillRef idx="3">
+            <a:schemeClr val="accent1"/>
+          </a:fillRef>
+          <a:effectRef idx="2">
+            <a:schemeClr val="accent1"/>
+          </a:effectRef>
+          <a:fontRef idx="minor">
+            <a:schemeClr val="lt1"/>
+          </a:fontRef>
+        </p:style>
+        <p:txBody>
+          <a:bodyPr rtlCol="0" anchor="ctr"/>
+          <a:lstStyle/>
+          <a:p>
+            <a:pPr algn="ctr"/>
+          </a:p>
+        </p:txBody>
+      </p:sp>
+      <p:pic>
+        <p:nvPicPr>
+          <p:cNvPr id="22" name="Zava branding logo" descr="image.png"/>
+          <p:cNvPicPr>
+            <a:picLocks noChangeAspect="1"/>
+          </p:cNvPicPr>
+          <p:nvPr/>
+        </p:nvPicPr>
+        <p:blipFill>
+          <a:blip r:embed="rId3"/>
+          <a:stretch>
+            <a:fillRect/>
+          </a:stretch>
+        </p:blipFill>
+        <p:spPr>
+          <a:xfrm>
+            <a:off x="11048695" y="109728"/>
+            <a:ext cx="960120" cy="335446"/>
+          </a:xfrm>
+          <a:prstGeom prst="rect">
+            <a:avLst/>
+          </a:prstGeom>
+        </p:spPr>
+      </p:pic>
     </p:spTree>
   </p:cSld>
   <p:clrMapOvr>
@@ -7356,6 +7677,73 @@
           </a:p>
         </p:txBody>
       </p:sp>
+      <p:sp>
+        <p:nvSpPr>
+          <p:cNvPr id="12" name="Zava logo contrast backing"/>
+          <p:cNvSpPr/>
+          <p:nvPr/>
+        </p:nvSpPr>
+        <p:spPr>
+          <a:xfrm>
+            <a:off x="11048695" y="109728"/>
+            <a:ext cx="960120" cy="335445"/>
+          </a:xfrm>
+          <a:prstGeom prst="rect">
+            <a:avLst/>
+          </a:prstGeom>
+          <a:solidFill>
+            <a:srgbClr val="FFFFFF"/>
+          </a:solidFill>
+          <a:ln>
+            <a:noFill/>
+          </a:ln>
+        </p:spPr>
+        <p:style>
+          <a:lnRef idx="1">
+            <a:schemeClr val="accent1"/>
+          </a:lnRef>
+          <a:fillRef idx="3">
+            <a:schemeClr val="accent1"/>
+          </a:fillRef>
+          <a:effectRef idx="2">
+            <a:schemeClr val="accent1"/>
+          </a:effectRef>
+          <a:fontRef idx="minor">
+            <a:schemeClr val="lt1"/>
+          </a:fontRef>
+        </p:style>
+        <p:txBody>
+          <a:bodyPr rtlCol="0" anchor="ctr"/>
+          <a:lstStyle/>
+          <a:p>
+            <a:pPr algn="ctr"/>
+          </a:p>
+        </p:txBody>
+      </p:sp>
+      <p:pic>
+        <p:nvPicPr>
+          <p:cNvPr id="13" name="Zava branding logo" descr="image.png"/>
+          <p:cNvPicPr>
+            <a:picLocks noChangeAspect="1"/>
+          </p:cNvPicPr>
+          <p:nvPr/>
+        </p:nvPicPr>
+        <p:blipFill>
+          <a:blip r:embed="rId3"/>
+          <a:stretch>
+            <a:fillRect/>
+          </a:stretch>
+        </p:blipFill>
+        <p:spPr>
+          <a:xfrm>
+            <a:off x="11048695" y="109728"/>
+            <a:ext cx="960120" cy="335446"/>
+          </a:xfrm>
+          <a:prstGeom prst="rect">
+            <a:avLst/>
+          </a:prstGeom>
+        </p:spPr>
+      </p:pic>
     </p:spTree>
   </p:cSld>
   <p:clrMapOvr>
@@ -8633,6 +9021,73 @@
           </a:p>
         </p:txBody>
       </p:sp>
+      <p:sp>
+        <p:nvSpPr>
+          <p:cNvPr id="25" name="Zava logo contrast backing"/>
+          <p:cNvSpPr/>
+          <p:nvPr/>
+        </p:nvSpPr>
+        <p:spPr>
+          <a:xfrm>
+            <a:off x="11048695" y="109728"/>
+            <a:ext cx="960120" cy="335445"/>
+          </a:xfrm>
+          <a:prstGeom prst="rect">
+            <a:avLst/>
+          </a:prstGeom>
+          <a:solidFill>
+            <a:srgbClr val="FFFFFF"/>
+          </a:solidFill>
+          <a:ln>
+            <a:noFill/>
+          </a:ln>
+        </p:spPr>
+        <p:style>
+          <a:lnRef idx="1">
+            <a:schemeClr val="accent1"/>
+          </a:lnRef>
+          <a:fillRef idx="3">
+            <a:schemeClr val="accent1"/>
+          </a:fillRef>
+          <a:effectRef idx="2">
+            <a:schemeClr val="accent1"/>
+          </a:effectRef>
+          <a:fontRef idx="minor">
+            <a:schemeClr val="lt1"/>
+          </a:fontRef>
+        </p:style>
+        <p:txBody>
+          <a:bodyPr rtlCol="0" anchor="ctr"/>
+          <a:lstStyle/>
+          <a:p>
+            <a:pPr algn="ctr"/>
+          </a:p>
+        </p:txBody>
+      </p:sp>
+      <p:pic>
+        <p:nvPicPr>
+          <p:cNvPr id="26" name="Zava branding logo" descr="image.png"/>
+          <p:cNvPicPr>
+            <a:picLocks noChangeAspect="1"/>
+          </p:cNvPicPr>
+          <p:nvPr/>
+        </p:nvPicPr>
+        <p:blipFill>
+          <a:blip r:embed="rId3"/>
+          <a:stretch>
+            <a:fillRect/>
+          </a:stretch>
+        </p:blipFill>
+        <p:spPr>
+          <a:xfrm>
+            <a:off x="11048695" y="109728"/>
+            <a:ext cx="960120" cy="335446"/>
+          </a:xfrm>
+          <a:prstGeom prst="rect">
+            <a:avLst/>
+          </a:prstGeom>
+        </p:spPr>
+      </p:pic>
     </p:spTree>
   </p:cSld>
   <p:clrMapOvr>
@@ -9072,6 +9527,73 @@
           </a:p>
         </p:txBody>
       </p:sp>
+      <p:sp>
+        <p:nvSpPr>
+          <p:cNvPr id="7" name="Zava logo contrast backing"/>
+          <p:cNvSpPr/>
+          <p:nvPr/>
+        </p:nvSpPr>
+        <p:spPr>
+          <a:xfrm>
+            <a:off x="11048695" y="109728"/>
+            <a:ext cx="960120" cy="335445"/>
+          </a:xfrm>
+          <a:prstGeom prst="rect">
+            <a:avLst/>
+          </a:prstGeom>
+          <a:solidFill>
+            <a:srgbClr val="FFFFFF"/>
+          </a:solidFill>
+          <a:ln>
+            <a:noFill/>
+          </a:ln>
+        </p:spPr>
+        <p:style>
+          <a:lnRef idx="1">
+            <a:schemeClr val="accent1"/>
+          </a:lnRef>
+          <a:fillRef idx="3">
+            <a:schemeClr val="accent1"/>
+          </a:fillRef>
+          <a:effectRef idx="2">
+            <a:schemeClr val="accent1"/>
+          </a:effectRef>
+          <a:fontRef idx="minor">
+            <a:schemeClr val="lt1"/>
+          </a:fontRef>
+        </p:style>
+        <p:txBody>
+          <a:bodyPr rtlCol="0" anchor="ctr"/>
+          <a:lstStyle/>
+          <a:p>
+            <a:pPr algn="ctr"/>
+          </a:p>
+        </p:txBody>
+      </p:sp>
+      <p:pic>
+        <p:nvPicPr>
+          <p:cNvPr id="8" name="Zava branding logo" descr="image.png"/>
+          <p:cNvPicPr>
+            <a:picLocks noChangeAspect="1"/>
+          </p:cNvPicPr>
+          <p:nvPr/>
+        </p:nvPicPr>
+        <p:blipFill>
+          <a:blip r:embed="rId3"/>
+          <a:stretch>
+            <a:fillRect/>
+          </a:stretch>
+        </p:blipFill>
+        <p:spPr>
+          <a:xfrm>
+            <a:off x="11048695" y="109728"/>
+            <a:ext cx="960120" cy="335446"/>
+          </a:xfrm>
+          <a:prstGeom prst="rect">
+            <a:avLst/>
+          </a:prstGeom>
+        </p:spPr>
+      </p:pic>
     </p:spTree>
   </p:cSld>
   <p:clrMapOvr>
@@ -10312,6 +10834,73 @@
           </a:p>
         </p:txBody>
       </p:sp>
+      <p:sp>
+        <p:nvSpPr>
+          <p:cNvPr id="21" name="Zava logo contrast backing"/>
+          <p:cNvSpPr/>
+          <p:nvPr/>
+        </p:nvSpPr>
+        <p:spPr>
+          <a:xfrm>
+            <a:off x="11048695" y="109728"/>
+            <a:ext cx="960120" cy="335445"/>
+          </a:xfrm>
+          <a:prstGeom prst="rect">
+            <a:avLst/>
+          </a:prstGeom>
+          <a:solidFill>
+            <a:srgbClr val="FFFFFF"/>
+          </a:solidFill>
+          <a:ln>
+            <a:noFill/>
+          </a:ln>
+        </p:spPr>
+        <p:style>
+          <a:lnRef idx="1">
+            <a:schemeClr val="accent1"/>
+          </a:lnRef>
+          <a:fillRef idx="3">
+            <a:schemeClr val="accent1"/>
+          </a:fillRef>
+          <a:effectRef idx="2">
+            <a:schemeClr val="accent1"/>
+          </a:effectRef>
+          <a:fontRef idx="minor">
+            <a:schemeClr val="lt1"/>
+          </a:fontRef>
+        </p:style>
+        <p:txBody>
+          <a:bodyPr rtlCol="0" anchor="ctr"/>
+          <a:lstStyle/>
+          <a:p>
+            <a:pPr algn="ctr"/>
+          </a:p>
+        </p:txBody>
+      </p:sp>
+      <p:pic>
+        <p:nvPicPr>
+          <p:cNvPr id="22" name="Zava branding logo" descr="image.png"/>
+          <p:cNvPicPr>
+            <a:picLocks noChangeAspect="1"/>
+          </p:cNvPicPr>
+          <p:nvPr/>
+        </p:nvPicPr>
+        <p:blipFill>
+          <a:blip r:embed="rId3"/>
+          <a:stretch>
+            <a:fillRect/>
+          </a:stretch>
+        </p:blipFill>
+        <p:spPr>
+          <a:xfrm>
+            <a:off x="11048695" y="109728"/>
+            <a:ext cx="960120" cy="335446"/>
+          </a:xfrm>
+          <a:prstGeom prst="rect">
+            <a:avLst/>
+          </a:prstGeom>
+        </p:spPr>
+      </p:pic>
     </p:spTree>
   </p:cSld>
   <p:clrMapOvr>
@@ -10752,6 +11341,73 @@
           </a:p>
         </p:txBody>
       </p:sp>
+      <p:sp>
+        <p:nvSpPr>
+          <p:cNvPr id="7" name="Zava logo contrast backing"/>
+          <p:cNvSpPr/>
+          <p:nvPr/>
+        </p:nvSpPr>
+        <p:spPr>
+          <a:xfrm>
+            <a:off x="11048695" y="109728"/>
+            <a:ext cx="960120" cy="335445"/>
+          </a:xfrm>
+          <a:prstGeom prst="rect">
+            <a:avLst/>
+          </a:prstGeom>
+          <a:solidFill>
+            <a:srgbClr val="FFFFFF"/>
+          </a:solidFill>
+          <a:ln>
+            <a:noFill/>
+          </a:ln>
+        </p:spPr>
+        <p:style>
+          <a:lnRef idx="1">
+            <a:schemeClr val="accent1"/>
+          </a:lnRef>
+          <a:fillRef idx="3">
+            <a:schemeClr val="accent1"/>
+          </a:fillRef>
+          <a:effectRef idx="2">
+            <a:schemeClr val="accent1"/>
+          </a:effectRef>
+          <a:fontRef idx="minor">
+            <a:schemeClr val="lt1"/>
+          </a:fontRef>
+        </p:style>
+        <p:txBody>
+          <a:bodyPr rtlCol="0" anchor="ctr"/>
+          <a:lstStyle/>
+          <a:p>
+            <a:pPr algn="ctr"/>
+          </a:p>
+        </p:txBody>
+      </p:sp>
+      <p:pic>
+        <p:nvPicPr>
+          <p:cNvPr id="8" name="Zava branding logo" descr="image.png"/>
+          <p:cNvPicPr>
+            <a:picLocks noChangeAspect="1"/>
+          </p:cNvPicPr>
+          <p:nvPr/>
+        </p:nvPicPr>
+        <p:blipFill>
+          <a:blip r:embed="rId3"/>
+          <a:stretch>
+            <a:fillRect/>
+          </a:stretch>
+        </p:blipFill>
+        <p:spPr>
+          <a:xfrm>
+            <a:off x="11048695" y="109728"/>
+            <a:ext cx="960120" cy="335446"/>
+          </a:xfrm>
+          <a:prstGeom prst="rect">
+            <a:avLst/>
+          </a:prstGeom>
+        </p:spPr>
+      </p:pic>
     </p:spTree>
   </p:cSld>
   <p:clrMapOvr>
@@ -11099,7 +11755,7 @@
                 </a:solidFill>
                 <a:latin typeface="Segoe UI"/>
               </a:rPr>
-              <a:t>Eight Proper North Homes perspectives to ask what the case never says</a:t>
+              <a:t>Eight Zava North Homes perspectives to ask what the case never says</a:t>
             </a:r>
           </a:p>
           <a:p>
@@ -11713,6 +12369,73 @@
           </a:p>
         </p:txBody>
       </p:sp>
+      <p:sp>
+        <p:nvSpPr>
+          <p:cNvPr id="15" name="Zava logo contrast backing"/>
+          <p:cNvSpPr/>
+          <p:nvPr/>
+        </p:nvSpPr>
+        <p:spPr>
+          <a:xfrm>
+            <a:off x="11048695" y="109728"/>
+            <a:ext cx="960120" cy="335445"/>
+          </a:xfrm>
+          <a:prstGeom prst="rect">
+            <a:avLst/>
+          </a:prstGeom>
+          <a:solidFill>
+            <a:srgbClr val="FFFFFF"/>
+          </a:solidFill>
+          <a:ln>
+            <a:noFill/>
+          </a:ln>
+        </p:spPr>
+        <p:style>
+          <a:lnRef idx="1">
+            <a:schemeClr val="accent1"/>
+          </a:lnRef>
+          <a:fillRef idx="3">
+            <a:schemeClr val="accent1"/>
+          </a:fillRef>
+          <a:effectRef idx="2">
+            <a:schemeClr val="accent1"/>
+          </a:effectRef>
+          <a:fontRef idx="minor">
+            <a:schemeClr val="lt1"/>
+          </a:fontRef>
+        </p:style>
+        <p:txBody>
+          <a:bodyPr rtlCol="0" anchor="ctr"/>
+          <a:lstStyle/>
+          <a:p>
+            <a:pPr algn="ctr"/>
+          </a:p>
+        </p:txBody>
+      </p:sp>
+      <p:pic>
+        <p:nvPicPr>
+          <p:cNvPr id="16" name="Zava branding logo" descr="image.png"/>
+          <p:cNvPicPr>
+            <a:picLocks noChangeAspect="1"/>
+          </p:cNvPicPr>
+          <p:nvPr/>
+        </p:nvPicPr>
+        <p:blipFill>
+          <a:blip r:embed="rId3"/>
+          <a:stretch>
+            <a:fillRect/>
+          </a:stretch>
+        </p:blipFill>
+        <p:spPr>
+          <a:xfrm>
+            <a:off x="11048695" y="109728"/>
+            <a:ext cx="960120" cy="335446"/>
+          </a:xfrm>
+          <a:prstGeom prst="rect">
+            <a:avLst/>
+          </a:prstGeom>
+        </p:spPr>
+      </p:pic>
     </p:spTree>
   </p:cSld>
   <p:clrMapOvr>
@@ -11861,7 +12584,7 @@
                 </a:solidFill>
                 <a:latin typeface="Segoe UI"/>
               </a:rPr>
-              <a:t>Proper North Homes: owner-confirmed not-for-profit, 26 Sep</a:t>
+              <a:t>Zava North Homes: owner-confirmed not-for-profit, 26 Sep</a:t>
             </a:r>
           </a:p>
           <a:p>
@@ -12329,6 +13052,73 @@
           </a:p>
         </p:txBody>
       </p:sp>
+      <p:sp>
+        <p:nvSpPr>
+          <p:cNvPr id="8" name="Zava logo contrast backing"/>
+          <p:cNvSpPr/>
+          <p:nvPr/>
+        </p:nvSpPr>
+        <p:spPr>
+          <a:xfrm>
+            <a:off x="11048695" y="109728"/>
+            <a:ext cx="960120" cy="335445"/>
+          </a:xfrm>
+          <a:prstGeom prst="rect">
+            <a:avLst/>
+          </a:prstGeom>
+          <a:solidFill>
+            <a:srgbClr val="FFFFFF"/>
+          </a:solidFill>
+          <a:ln>
+            <a:noFill/>
+          </a:ln>
+        </p:spPr>
+        <p:style>
+          <a:lnRef idx="1">
+            <a:schemeClr val="accent1"/>
+          </a:lnRef>
+          <a:fillRef idx="3">
+            <a:schemeClr val="accent1"/>
+          </a:fillRef>
+          <a:effectRef idx="2">
+            <a:schemeClr val="accent1"/>
+          </a:effectRef>
+          <a:fontRef idx="minor">
+            <a:schemeClr val="lt1"/>
+          </a:fontRef>
+        </p:style>
+        <p:txBody>
+          <a:bodyPr rtlCol="0" anchor="ctr"/>
+          <a:lstStyle/>
+          <a:p>
+            <a:pPr algn="ctr"/>
+          </a:p>
+        </p:txBody>
+      </p:sp>
+      <p:pic>
+        <p:nvPicPr>
+          <p:cNvPr id="9" name="Zava branding logo" descr="image.png"/>
+          <p:cNvPicPr>
+            <a:picLocks noChangeAspect="1"/>
+          </p:cNvPicPr>
+          <p:nvPr/>
+        </p:nvPicPr>
+        <p:blipFill>
+          <a:blip r:embed="rId3"/>
+          <a:stretch>
+            <a:fillRect/>
+          </a:stretch>
+        </p:blipFill>
+        <p:spPr>
+          <a:xfrm>
+            <a:off x="11048695" y="109728"/>
+            <a:ext cx="960120" cy="335446"/>
+          </a:xfrm>
+          <a:prstGeom prst="rect">
+            <a:avLst/>
+          </a:prstGeom>
+        </p:spPr>
+      </p:pic>
     </p:spTree>
   </p:cSld>
   <p:clrMapOvr>
@@ -13312,7 +14102,7 @@
                 </a:solidFill>
                 <a:latin typeface="Segoe UI"/>
               </a:rPr>
-              <a:t>Whether Proper North Homes operates in either area</a:t>
+              <a:t>Whether Zava North Homes operates in either area</a:t>
             </a:r>
           </a:p>
         </p:txBody>
@@ -13485,6 +14275,73 @@
           </a:p>
         </p:txBody>
       </p:sp>
+      <p:sp>
+        <p:nvSpPr>
+          <p:cNvPr id="21" name="Zava logo contrast backing"/>
+          <p:cNvSpPr/>
+          <p:nvPr/>
+        </p:nvSpPr>
+        <p:spPr>
+          <a:xfrm>
+            <a:off x="11048695" y="109728"/>
+            <a:ext cx="960120" cy="335445"/>
+          </a:xfrm>
+          <a:prstGeom prst="rect">
+            <a:avLst/>
+          </a:prstGeom>
+          <a:solidFill>
+            <a:srgbClr val="FFFFFF"/>
+          </a:solidFill>
+          <a:ln>
+            <a:noFill/>
+          </a:ln>
+        </p:spPr>
+        <p:style>
+          <a:lnRef idx="1">
+            <a:schemeClr val="accent1"/>
+          </a:lnRef>
+          <a:fillRef idx="3">
+            <a:schemeClr val="accent1"/>
+          </a:fillRef>
+          <a:effectRef idx="2">
+            <a:schemeClr val="accent1"/>
+          </a:effectRef>
+          <a:fontRef idx="minor">
+            <a:schemeClr val="lt1"/>
+          </a:fontRef>
+        </p:style>
+        <p:txBody>
+          <a:bodyPr rtlCol="0" anchor="ctr"/>
+          <a:lstStyle/>
+          <a:p>
+            <a:pPr algn="ctr"/>
+          </a:p>
+        </p:txBody>
+      </p:sp>
+      <p:pic>
+        <p:nvPicPr>
+          <p:cNvPr id="22" name="Zava branding logo" descr="image.png"/>
+          <p:cNvPicPr>
+            <a:picLocks noChangeAspect="1"/>
+          </p:cNvPicPr>
+          <p:nvPr/>
+        </p:nvPicPr>
+        <p:blipFill>
+          <a:blip r:embed="rId3"/>
+          <a:stretch>
+            <a:fillRect/>
+          </a:stretch>
+        </p:blipFill>
+        <p:spPr>
+          <a:xfrm>
+            <a:off x="11048695" y="109728"/>
+            <a:ext cx="960120" cy="335446"/>
+          </a:xfrm>
+          <a:prstGeom prst="rect">
+            <a:avLst/>
+          </a:prstGeom>
+        </p:spPr>
+      </p:pic>
     </p:spTree>
   </p:cSld>
   <p:clrMapOvr>
@@ -14306,6 +15163,73 @@
           </a:p>
         </p:txBody>
       </p:sp>
+      <p:sp>
+        <p:nvSpPr>
+          <p:cNvPr id="22" name="Zava logo contrast backing"/>
+          <p:cNvSpPr/>
+          <p:nvPr/>
+        </p:nvSpPr>
+        <p:spPr>
+          <a:xfrm>
+            <a:off x="11048695" y="109728"/>
+            <a:ext cx="960120" cy="335445"/>
+          </a:xfrm>
+          <a:prstGeom prst="rect">
+            <a:avLst/>
+          </a:prstGeom>
+          <a:solidFill>
+            <a:srgbClr val="FFFFFF"/>
+          </a:solidFill>
+          <a:ln>
+            <a:noFill/>
+          </a:ln>
+        </p:spPr>
+        <p:style>
+          <a:lnRef idx="1">
+            <a:schemeClr val="accent1"/>
+          </a:lnRef>
+          <a:fillRef idx="3">
+            <a:schemeClr val="accent1"/>
+          </a:fillRef>
+          <a:effectRef idx="2">
+            <a:schemeClr val="accent1"/>
+          </a:effectRef>
+          <a:fontRef idx="minor">
+            <a:schemeClr val="lt1"/>
+          </a:fontRef>
+        </p:style>
+        <p:txBody>
+          <a:bodyPr rtlCol="0" anchor="ctr"/>
+          <a:lstStyle/>
+          <a:p>
+            <a:pPr algn="ctr"/>
+          </a:p>
+        </p:txBody>
+      </p:sp>
+      <p:pic>
+        <p:nvPicPr>
+          <p:cNvPr id="23" name="Zava branding logo" descr="image.png"/>
+          <p:cNvPicPr>
+            <a:picLocks noChangeAspect="1"/>
+          </p:cNvPicPr>
+          <p:nvPr/>
+        </p:nvPicPr>
+        <p:blipFill>
+          <a:blip r:embed="rId3"/>
+          <a:stretch>
+            <a:fillRect/>
+          </a:stretch>
+        </p:blipFill>
+        <p:spPr>
+          <a:xfrm>
+            <a:off x="11048695" y="109728"/>
+            <a:ext cx="960120" cy="335446"/>
+          </a:xfrm>
+          <a:prstGeom prst="rect">
+            <a:avLst/>
+          </a:prstGeom>
+        </p:spPr>
+      </p:pic>
     </p:spTree>
   </p:cSld>
   <p:clrMapOvr>
@@ -15189,6 +16113,73 @@
           </a:p>
         </p:txBody>
       </p:sp>
+      <p:sp>
+        <p:nvSpPr>
+          <p:cNvPr id="8" name="Zava logo contrast backing"/>
+          <p:cNvSpPr/>
+          <p:nvPr/>
+        </p:nvSpPr>
+        <p:spPr>
+          <a:xfrm>
+            <a:off x="11048695" y="109728"/>
+            <a:ext cx="960120" cy="335445"/>
+          </a:xfrm>
+          <a:prstGeom prst="rect">
+            <a:avLst/>
+          </a:prstGeom>
+          <a:solidFill>
+            <a:srgbClr val="FFFFFF"/>
+          </a:solidFill>
+          <a:ln>
+            <a:noFill/>
+          </a:ln>
+        </p:spPr>
+        <p:style>
+          <a:lnRef idx="1">
+            <a:schemeClr val="accent1"/>
+          </a:lnRef>
+          <a:fillRef idx="3">
+            <a:schemeClr val="accent1"/>
+          </a:fillRef>
+          <a:effectRef idx="2">
+            <a:schemeClr val="accent1"/>
+          </a:effectRef>
+          <a:fontRef idx="minor">
+            <a:schemeClr val="lt1"/>
+          </a:fontRef>
+        </p:style>
+        <p:txBody>
+          <a:bodyPr rtlCol="0" anchor="ctr"/>
+          <a:lstStyle/>
+          <a:p>
+            <a:pPr algn="ctr"/>
+          </a:p>
+        </p:txBody>
+      </p:sp>
+      <p:pic>
+        <p:nvPicPr>
+          <p:cNvPr id="9" name="Zava branding logo" descr="image.png"/>
+          <p:cNvPicPr>
+            <a:picLocks noChangeAspect="1"/>
+          </p:cNvPicPr>
+          <p:nvPr/>
+        </p:nvPicPr>
+        <p:blipFill>
+          <a:blip r:embed="rId3"/>
+          <a:stretch>
+            <a:fillRect/>
+          </a:stretch>
+        </p:blipFill>
+        <p:spPr>
+          <a:xfrm>
+            <a:off x="11048695" y="109728"/>
+            <a:ext cx="960120" cy="335446"/>
+          </a:xfrm>
+          <a:prstGeom prst="rect">
+            <a:avLst/>
+          </a:prstGeom>
+        </p:spPr>
+      </p:pic>
     </p:spTree>
   </p:cSld>
   <p:clrMapOvr>
@@ -15858,6 +16849,73 @@
           </a:p>
         </p:txBody>
       </p:sp>
+      <p:sp>
+        <p:nvSpPr>
+          <p:cNvPr id="12" name="Zava logo contrast backing"/>
+          <p:cNvSpPr/>
+          <p:nvPr/>
+        </p:nvSpPr>
+        <p:spPr>
+          <a:xfrm>
+            <a:off x="11048695" y="109728"/>
+            <a:ext cx="960120" cy="335445"/>
+          </a:xfrm>
+          <a:prstGeom prst="rect">
+            <a:avLst/>
+          </a:prstGeom>
+          <a:solidFill>
+            <a:srgbClr val="FFFFFF"/>
+          </a:solidFill>
+          <a:ln>
+            <a:noFill/>
+          </a:ln>
+        </p:spPr>
+        <p:style>
+          <a:lnRef idx="1">
+            <a:schemeClr val="accent1"/>
+          </a:lnRef>
+          <a:fillRef idx="3">
+            <a:schemeClr val="accent1"/>
+          </a:fillRef>
+          <a:effectRef idx="2">
+            <a:schemeClr val="accent1"/>
+          </a:effectRef>
+          <a:fontRef idx="minor">
+            <a:schemeClr val="lt1"/>
+          </a:fontRef>
+        </p:style>
+        <p:txBody>
+          <a:bodyPr rtlCol="0" anchor="ctr"/>
+          <a:lstStyle/>
+          <a:p>
+            <a:pPr algn="ctr"/>
+          </a:p>
+        </p:txBody>
+      </p:sp>
+      <p:pic>
+        <p:nvPicPr>
+          <p:cNvPr id="13" name="Zava branding logo" descr="image.png"/>
+          <p:cNvPicPr>
+            <a:picLocks noChangeAspect="1"/>
+          </p:cNvPicPr>
+          <p:nvPr/>
+        </p:nvPicPr>
+        <p:blipFill>
+          <a:blip r:embed="rId3"/>
+          <a:stretch>
+            <a:fillRect/>
+          </a:stretch>
+        </p:blipFill>
+        <p:spPr>
+          <a:xfrm>
+            <a:off x="11048695" y="109728"/>
+            <a:ext cx="960120" cy="335446"/>
+          </a:xfrm>
+          <a:prstGeom prst="rect">
+            <a:avLst/>
+          </a:prstGeom>
+        </p:spPr>
+      </p:pic>
     </p:spTree>
   </p:cSld>
   <p:clrMapOvr>
@@ -16277,6 +17335,73 @@
           </a:p>
         </p:txBody>
       </p:sp>
+      <p:sp>
+        <p:nvSpPr>
+          <p:cNvPr id="7" name="Zava logo contrast backing"/>
+          <p:cNvSpPr/>
+          <p:nvPr/>
+        </p:nvSpPr>
+        <p:spPr>
+          <a:xfrm>
+            <a:off x="11048695" y="109728"/>
+            <a:ext cx="960120" cy="335445"/>
+          </a:xfrm>
+          <a:prstGeom prst="rect">
+            <a:avLst/>
+          </a:prstGeom>
+          <a:solidFill>
+            <a:srgbClr val="FFFFFF"/>
+          </a:solidFill>
+          <a:ln>
+            <a:noFill/>
+          </a:ln>
+        </p:spPr>
+        <p:style>
+          <a:lnRef idx="1">
+            <a:schemeClr val="accent1"/>
+          </a:lnRef>
+          <a:fillRef idx="3">
+            <a:schemeClr val="accent1"/>
+          </a:fillRef>
+          <a:effectRef idx="2">
+            <a:schemeClr val="accent1"/>
+          </a:effectRef>
+          <a:fontRef idx="minor">
+            <a:schemeClr val="lt1"/>
+          </a:fontRef>
+        </p:style>
+        <p:txBody>
+          <a:bodyPr rtlCol="0" anchor="ctr"/>
+          <a:lstStyle/>
+          <a:p>
+            <a:pPr algn="ctr"/>
+          </a:p>
+        </p:txBody>
+      </p:sp>
+      <p:pic>
+        <p:nvPicPr>
+          <p:cNvPr id="8" name="Zava branding logo" descr="image.png"/>
+          <p:cNvPicPr>
+            <a:picLocks noChangeAspect="1"/>
+          </p:cNvPicPr>
+          <p:nvPr/>
+        </p:nvPicPr>
+        <p:blipFill>
+          <a:blip r:embed="rId3"/>
+          <a:stretch>
+            <a:fillRect/>
+          </a:stretch>
+        </p:blipFill>
+        <p:spPr>
+          <a:xfrm>
+            <a:off x="11048695" y="109728"/>
+            <a:ext cx="960120" cy="335446"/>
+          </a:xfrm>
+          <a:prstGeom prst="rect">
+            <a:avLst/>
+          </a:prstGeom>
+        </p:spPr>
+      </p:pic>
     </p:spTree>
   </p:cSld>
   <p:clrMapOvr>

</xml_diff>